<commit_message>
Coupon - Working with create coupon
</commit_message>
<xml_diff>
--- a/.lessons/64 Backend Coupon System Setup/1 Coupon - Creating necessary files and designs/1.pptx
+++ b/.lessons/64 Backend Coupon System Setup/1 Coupon - Creating necessary files and designs/1.pptx
@@ -3522,14 +3522,76 @@
         </p:nvPicPr>
         <p:blipFill>
           <a:blip r:embed="rId2"/>
+          <a:srcRect b="72539"/>
           <a:stretch>
             <a:fillRect/>
           </a:stretch>
         </p:blipFill>
         <p:spPr>
           <a:xfrm>
-            <a:off x="1175651" y="1866682"/>
-            <a:ext cx="9840698" cy="3124636"/>
+            <a:off x="1175651" y="924573"/>
+            <a:ext cx="9840698" cy="858045"/>
+          </a:xfrm>
+          <a:prstGeom prst="rect">
+            <a:avLst/>
+          </a:prstGeom>
+        </p:spPr>
+      </p:pic>
+      <p:pic>
+        <p:nvPicPr>
+          <p:cNvPr id="2" name="Picture 1">
+            <a:extLst>
+              <a:ext uri="{FF2B5EF4-FFF2-40B4-BE49-F238E27FC236}">
+                <a16:creationId xmlns:a16="http://schemas.microsoft.com/office/drawing/2014/main" id="{F7A6660E-D5BF-CC2E-CC26-7BAEFAA3B3AF}"/>
+              </a:ext>
+            </a:extLst>
+          </p:cNvPr>
+          <p:cNvPicPr>
+            <a:picLocks noChangeAspect="1"/>
+          </p:cNvPicPr>
+          <p:nvPr/>
+        </p:nvPicPr>
+        <p:blipFill>
+          <a:blip r:embed="rId2"/>
+          <a:srcRect t="57612"/>
+          <a:stretch>
+            <a:fillRect/>
+          </a:stretch>
+        </p:blipFill>
+        <p:spPr>
+          <a:xfrm>
+            <a:off x="1175651" y="5075382"/>
+            <a:ext cx="9840698" cy="1324481"/>
+          </a:xfrm>
+          <a:prstGeom prst="rect">
+            <a:avLst/>
+          </a:prstGeom>
+        </p:spPr>
+      </p:pic>
+      <p:pic>
+        <p:nvPicPr>
+          <p:cNvPr id="6" name="Picture 5">
+            <a:extLst>
+              <a:ext uri="{FF2B5EF4-FFF2-40B4-BE49-F238E27FC236}">
+                <a16:creationId xmlns:a16="http://schemas.microsoft.com/office/drawing/2014/main" id="{C6CE6CEF-87D7-9292-3D4D-C155C0EB5360}"/>
+              </a:ext>
+            </a:extLst>
+          </p:cNvPr>
+          <p:cNvPicPr>
+            <a:picLocks noChangeAspect="1"/>
+          </p:cNvPicPr>
+          <p:nvPr/>
+        </p:nvPicPr>
+        <p:blipFill>
+          <a:blip r:embed="rId3"/>
+          <a:stretch>
+            <a:fillRect/>
+          </a:stretch>
+        </p:blipFill>
+        <p:spPr>
+          <a:xfrm>
+            <a:off x="1318546" y="2585920"/>
+            <a:ext cx="9554908" cy="1686160"/>
           </a:xfrm>
           <a:prstGeom prst="rect">
             <a:avLst/>

</xml_diff>